<commit_message>
replace powerpoint example with self hosted https://github.com/WolfgangFahl/pySemanticSlides/raw/refs/heads/main/examples/semanticslides/SemanticSlides.pptx
</commit_message>
<xml_diff>
--- a/simplegraph-powerpoint/QueenVictoria.pptx
+++ b/simplegraph-powerpoint/QueenVictoria.pptx
@@ -611,21 +611,49 @@
             <a:pPr lvl="0"/>
             <a:r>
               <a:rPr lang="en-US"/>
-              <a:t>date of birth (P569) = 1819-06-24</a:t>
+              <a:t>place of birth (P19) = Kensington Palace (Q207385)</a:t>
             </a:r>
           </a:p>
           <a:p>
             <a:pPr lvl="0"/>
             <a:r>
               <a:rPr lang="en-US"/>
-              <a:t>date of death (P570) = 1901-02-22</a:t>
+              <a:t>sex or gender (P21) = female (Q6581072)</a:t>
             </a:r>
           </a:p>
           <a:p>
             <a:pPr lvl="0"/>
             <a:r>
               <a:rPr lang="en-US"/>
-              <a:t>place of birth (P19) = Kensington Palace (Q207385)</a:t>
+              <a:t>place of death (P20) = Osborne House (Q565155)</a:t>
+            </a:r>
+          </a:p>
+          <a:p>
+            <a:pPr lvl="0"/>
+            <a:r>
+              <a:rPr lang="en-US"/>
+              <a:t>father (P22) = Prince Edward Augustus, Duke of Kent and Strathearn (Q157009)</a:t>
+            </a:r>
+          </a:p>
+          <a:p>
+            <a:pPr lvl="0"/>
+            <a:r>
+              <a:rPr lang="en-US"/>
+              <a:t>mother (P25) = Princess Victoria of Saxe-Coburg-Saalfeld (Q58067)</a:t>
+            </a:r>
+          </a:p>
+          <a:p>
+            <a:pPr lvl="0"/>
+            <a:r>
+              <a:rPr lang="en-US"/>
+              <a:t>date of birth (P569) = 1819-05-24</a:t>
+            </a:r>
+          </a:p>
+          <a:p>
+            <a:pPr lvl="0"/>
+            <a:r>
+              <a:rPr lang="en-US"/>
+              <a:t>date of death (P570) = 1901-01-22</a:t>
             </a:r>
           </a:p>
           <a:p>
@@ -639,35 +667,7 @@
             <a:pPr lvl="0"/>
             <a:r>
               <a:rPr lang="en-US"/>
-              <a:t>sex or gender (P21) = female (Q6581072)</a:t>
-            </a:r>
-          </a:p>
-          <a:p>
-            <a:pPr lvl="0"/>
-            <a:r>
-              <a:rPr lang="en-US"/>
               <a:t>signature (P109) = Queen Victoria Signature.svg</a:t>
-            </a:r>
-          </a:p>
-          <a:p>
-            <a:pPr lvl="0"/>
-            <a:r>
-              <a:rPr lang="en-US"/>
-              <a:t>place of death (P20) = Osborne House (Q565155)</a:t>
-            </a:r>
-          </a:p>
-          <a:p>
-            <a:pPr lvl="0"/>
-            <a:r>
-              <a:rPr lang="en-US"/>
-              <a:t>father (P22) = Prince Edward Augustus, Duke of Kent and Strathearn (Q157009)</a:t>
-            </a:r>
-          </a:p>
-          <a:p>
-            <a:pPr lvl="0"/>
-            <a:r>
-              <a:rPr lang="en-US"/>
-              <a:t>mother (P25) = Princess Victoria of Saxe-Coburg-Saalfeld (Q58067)</a:t>
             </a:r>
           </a:p>
         </p:txBody>
@@ -906,6 +906,13 @@
             <a:pPr lvl="0"/>
             <a:r>
               <a:rPr lang="en-US"/>
+              <a:t>signature (P109) = Princess Beatrice's signature.svg</a:t>
+            </a:r>
+          </a:p>
+          <a:p>
+            <a:pPr lvl="0"/>
+            <a:r>
+              <a:rPr lang="en-US"/>
               <a:t>father (P22) = Albert, Prince Consort (Q152245)</a:t>
             </a:r>
           </a:p>
@@ -920,14 +927,14 @@
             <a:pPr lvl="0"/>
             <a:r>
               <a:rPr lang="en-US"/>
-              <a:t>date of birth (P569) = 1857-05-14</a:t>
+              <a:t>date of birth (P569) = 1857-04-14</a:t>
             </a:r>
           </a:p>
           <a:p>
             <a:pPr lvl="0"/>
             <a:r>
               <a:rPr lang="en-US"/>
-              <a:t>date of death (P570) = 1944-11-26</a:t>
+              <a:t>date of death (P570) = 1944-10-26</a:t>
             </a:r>
           </a:p>
           <a:p>
@@ -1152,6 +1159,34 @@
             <a:pPr lvl="0"/>
             <a:r>
               <a:rPr lang="en-US"/>
+              <a:t>date of birth (P569) = 1840-11-21</a:t>
+            </a:r>
+          </a:p>
+          <a:p>
+            <a:pPr lvl="0"/>
+            <a:r>
+              <a:rPr lang="en-US"/>
+              <a:t>date of death (P570) = 1901-08-05</a:t>
+            </a:r>
+          </a:p>
+          <a:p>
+            <a:pPr lvl="0"/>
+            <a:r>
+              <a:rPr lang="en-US"/>
+              <a:t>place of birth (P19) = [http://www.wikidata.org/entity/Q42182 (item), http://www.wikidata.org/entity/Q84 (item)]</a:t>
+            </a:r>
+          </a:p>
+          <a:p>
+            <a:pPr lvl="0"/>
+            <a:r>
+              <a:rPr lang="en-US"/>
+              <a:t>monogram (P1543) = Royal Monogram of Empress Victoria of Germany.svg</a:t>
+            </a:r>
+          </a:p>
+          <a:p>
+            <a:pPr lvl="0"/>
+            <a:r>
+              <a:rPr lang="en-US"/>
               <a:t>sex or gender (P21) = female (Q6581072)</a:t>
             </a:r>
           </a:p>
@@ -1166,6 +1201,13 @@
             <a:pPr lvl="0"/>
             <a:r>
               <a:rPr lang="en-US"/>
+              <a:t>signature (P109) = Signature of Princess Royal Victoria.svg</a:t>
+            </a:r>
+          </a:p>
+          <a:p>
+            <a:pPr lvl="0"/>
+            <a:r>
+              <a:rPr lang="en-US"/>
               <a:t>father (P22) = Albert, Prince Consort (Q152245)</a:t>
             </a:r>
           </a:p>
@@ -1174,27 +1216,6 @@
             <a:r>
               <a:rPr lang="en-US"/>
               <a:t>mother (P25) = Queen Victoria (Q9439)</a:t>
-            </a:r>
-          </a:p>
-          <a:p>
-            <a:pPr lvl="0"/>
-            <a:r>
-              <a:rPr lang="en-US"/>
-              <a:t>date of birth (P569) = 1840-12-21</a:t>
-            </a:r>
-          </a:p>
-          <a:p>
-            <a:pPr lvl="0"/>
-            <a:r>
-              <a:rPr lang="en-US"/>
-              <a:t>date of death (P570) = 1901-09-05</a:t>
-            </a:r>
-          </a:p>
-          <a:p>
-            <a:pPr lvl="0"/>
-            <a:r>
-              <a:rPr lang="en-US"/>
-              <a:t>place of birth (P19) = [http://www.wikidata.org/entity/Q42182 (item), http://www.wikidata.org/entity/Q84 (item)]</a:t>
             </a:r>
           </a:p>
         </p:txBody>
@@ -1412,28 +1433,7 @@
             <a:pPr lvl="0"/>
             <a:r>
               <a:rPr lang="en-US"/>
-              <a:t>date of birth (P569) = 1841-12-09</a:t>
-            </a:r>
-          </a:p>
-          <a:p>
-            <a:pPr lvl="0"/>
-            <a:r>
-              <a:rPr lang="en-US"/>
-              <a:t>date of death (P570) = 1910-06-06</a:t>
-            </a:r>
-          </a:p>
-          <a:p>
-            <a:pPr lvl="0"/>
-            <a:r>
-              <a:rPr lang="en-US"/>
               <a:t>place of birth (P19) = Buckingham Palace (Q42182)</a:t>
-            </a:r>
-          </a:p>
-          <a:p>
-            <a:pPr lvl="0"/>
-            <a:r>
-              <a:rPr lang="en-US"/>
-              <a:t>monogram (P1543) = Royal Monogram of King Edward VII of Great Britain.svg</a:t>
             </a:r>
           </a:p>
           <a:p>
@@ -1447,13 +1447,6 @@
             <a:pPr lvl="0"/>
             <a:r>
               <a:rPr lang="en-US"/>
-              <a:t>signature (P109) = EdwardVII Signature.svg</a:t>
-            </a:r>
-          </a:p>
-          <a:p>
-            <a:pPr lvl="0"/>
-            <a:r>
-              <a:rPr lang="en-US"/>
               <a:t>place of death (P20) = Buckingham Palace (Q42182)</a:t>
             </a:r>
           </a:p>
@@ -1469,6 +1462,34 @@
             <a:r>
               <a:rPr lang="en-US"/>
               <a:t>mother (P25) = Queen Victoria (Q9439)</a:t>
+            </a:r>
+          </a:p>
+          <a:p>
+            <a:pPr lvl="0"/>
+            <a:r>
+              <a:rPr lang="en-US"/>
+              <a:t>date of birth (P569) = 1841-11-09</a:t>
+            </a:r>
+          </a:p>
+          <a:p>
+            <a:pPr lvl="0"/>
+            <a:r>
+              <a:rPr lang="en-US"/>
+              <a:t>date of death (P570) = 1910-05-06</a:t>
+            </a:r>
+          </a:p>
+          <a:p>
+            <a:pPr lvl="0"/>
+            <a:r>
+              <a:rPr lang="en-US"/>
+              <a:t>monogram (P1543) = Cypher of Edward VII.svg</a:t>
+            </a:r>
+          </a:p>
+          <a:p>
+            <a:pPr lvl="0"/>
+            <a:r>
+              <a:rPr lang="en-US"/>
+              <a:t>signature (P109) = EdwardVII Signature.svg</a:t>
             </a:r>
           </a:p>
         </p:txBody>
@@ -1686,6 +1707,27 @@
             <a:pPr lvl="0"/>
             <a:r>
               <a:rPr lang="en-US"/>
+              <a:t>date of birth (P569) = 1843-04-25</a:t>
+            </a:r>
+          </a:p>
+          <a:p>
+            <a:pPr lvl="0"/>
+            <a:r>
+              <a:rPr lang="en-US"/>
+              <a:t>date of death (P570) = 1878-12-14</a:t>
+            </a:r>
+          </a:p>
+          <a:p>
+            <a:pPr lvl="0"/>
+            <a:r>
+              <a:rPr lang="en-US"/>
+              <a:t>place of birth (P19) = Buckingham Palace (Q42182)</a:t>
+            </a:r>
+          </a:p>
+          <a:p>
+            <a:pPr lvl="0"/>
+            <a:r>
+              <a:rPr lang="en-US"/>
               <a:t>sex or gender (P21) = female (Q6581072)</a:t>
             </a:r>
           </a:p>
@@ -1700,6 +1742,13 @@
             <a:pPr lvl="0"/>
             <a:r>
               <a:rPr lang="en-US"/>
+              <a:t>signature (P109) = Princess Alice's signature.svg</a:t>
+            </a:r>
+          </a:p>
+          <a:p>
+            <a:pPr lvl="0"/>
+            <a:r>
+              <a:rPr lang="en-US"/>
               <a:t>father (P22) = Albert, Prince Consort (Q152245)</a:t>
             </a:r>
           </a:p>
@@ -1708,27 +1757,6 @@
             <a:r>
               <a:rPr lang="en-US"/>
               <a:t>mother (P25) = Queen Victoria (Q9439)</a:t>
-            </a:r>
-          </a:p>
-          <a:p>
-            <a:pPr lvl="0"/>
-            <a:r>
-              <a:rPr lang="en-US"/>
-              <a:t>date of birth (P569) = 1843-05-25</a:t>
-            </a:r>
-          </a:p>
-          <a:p>
-            <a:pPr lvl="0"/>
-            <a:r>
-              <a:rPr lang="en-US"/>
-              <a:t>date of death (P570) = 1879-01-14</a:t>
-            </a:r>
-          </a:p>
-          <a:p>
-            <a:pPr lvl="0"/>
-            <a:r>
-              <a:rPr lang="en-US"/>
-              <a:t>place of birth (P19) = London (Q84)</a:t>
             </a:r>
           </a:p>
         </p:txBody>
@@ -1946,6 +1974,34 @@
             <a:pPr lvl="0"/>
             <a:r>
               <a:rPr lang="en-US"/>
+              <a:t>date of birth (P569) = 1844-08-06</a:t>
+            </a:r>
+          </a:p>
+          <a:p>
+            <a:pPr lvl="0"/>
+            <a:r>
+              <a:rPr lang="en-US"/>
+              <a:t>date of death (P570) = [1900-07-30 (Prec.: day [-0 .. +0], PCal: Gregorian), 1900-07-31 (Prec.: day [-0 .. +0], PCal: Gregorian)]</a:t>
+            </a:r>
+          </a:p>
+          <a:p>
+            <a:pPr lvl="0"/>
+            <a:r>
+              <a:rPr lang="en-US"/>
+              <a:t>place of birth (P19) = Windsor Castle (Q42646)</a:t>
+            </a:r>
+          </a:p>
+          <a:p>
+            <a:pPr lvl="0"/>
+            <a:r>
+              <a:rPr lang="en-US"/>
+              <a:t>monogram (P1543) = ["Royal Monogram of Prince Alfred as Duke of Edinburgh.svg", "Royal Monogram of Prince Alfred as Duke of Saxe-Coburg and Gotha.svg"]</a:t>
+            </a:r>
+          </a:p>
+          <a:p>
+            <a:pPr lvl="0"/>
+            <a:r>
+              <a:rPr lang="en-US"/>
               <a:t>sex or gender (P21) = male (Q6581097)</a:t>
             </a:r>
           </a:p>
@@ -1960,6 +2016,13 @@
             <a:pPr lvl="0"/>
             <a:r>
               <a:rPr lang="en-US"/>
+              <a:t>signature (P109) = Prince Alfred's signature.svg</a:t>
+            </a:r>
+          </a:p>
+          <a:p>
+            <a:pPr lvl="0"/>
+            <a:r>
+              <a:rPr lang="en-US"/>
               <a:t>father (P22) = Albert, Prince Consort (Q152245)</a:t>
             </a:r>
           </a:p>
@@ -1968,27 +2031,6 @@
             <a:r>
               <a:rPr lang="en-US"/>
               <a:t>mother (P25) = Queen Victoria (Q9439)</a:t>
-            </a:r>
-          </a:p>
-          <a:p>
-            <a:pPr lvl="0"/>
-            <a:r>
-              <a:rPr lang="en-US"/>
-              <a:t>date of birth (P569) = 1844-09-06</a:t>
-            </a:r>
-          </a:p>
-          <a:p>
-            <a:pPr lvl="0"/>
-            <a:r>
-              <a:rPr lang="en-US"/>
-              <a:t>date of death (P570) = 1900-08-30</a:t>
-            </a:r>
-          </a:p>
-          <a:p>
-            <a:pPr lvl="0"/>
-            <a:r>
-              <a:rPr lang="en-US"/>
-              <a:t>place of birth (P19) = Windsor Castle (Q42646)</a:t>
             </a:r>
           </a:p>
         </p:txBody>
@@ -2206,21 +2248,21 @@
             <a:pPr lvl="0"/>
             <a:r>
               <a:rPr lang="en-US"/>
-              <a:t>date of birth (P569) = [1846-05-25 (Prec.: day [-0 .. +0], PCal: Gregorian), 1846-05-26 (Prec.: day [-0 .. +0], PCal: Gregorian)]</a:t>
+              <a:t>sex or gender (P21) = female (Q6581072)</a:t>
             </a:r>
           </a:p>
           <a:p>
             <a:pPr lvl="0"/>
             <a:r>
               <a:rPr lang="en-US"/>
-              <a:t>sex or gender (P21) = female (Q6581072)</a:t>
+              <a:t>place of death (P20) = Schomberg House (Q7432105)</a:t>
             </a:r>
           </a:p>
           <a:p>
             <a:pPr lvl="0"/>
             <a:r>
               <a:rPr lang="en-US"/>
-              <a:t>place of death (P20) = London (Q84)</a:t>
+              <a:t>signature (P109) = Princess Helena's signature.svg</a:t>
             </a:r>
           </a:p>
           <a:p>
@@ -2241,7 +2283,14 @@
             <a:pPr lvl="0"/>
             <a:r>
               <a:rPr lang="en-US"/>
-              <a:t>date of death (P570) = 1923-07-09</a:t>
+              <a:t>date of birth (P569) = [1846-05-25 (Prec.: day [-0 .. +0], PCal: Gregorian), 1846-05-26 (Prec.: day [-0 .. +0], PCal: Gregorian), 1846-01-01 (Prec.: year [-0 .. +0], PCal: Gregorian)]</a:t>
+            </a:r>
+          </a:p>
+          <a:p>
+            <a:pPr lvl="0"/>
+            <a:r>
+              <a:rPr lang="en-US"/>
+              <a:t>date of death (P570) = [1923-06-09 (Prec.: day [-0 .. +0], PCal: Gregorian), 1923-01-01 (Prec.: year [-0 .. +0], PCal: Gregorian)]</a:t>
             </a:r>
           </a:p>
           <a:p>
@@ -2466,6 +2515,27 @@
             <a:pPr lvl="0"/>
             <a:r>
               <a:rPr lang="en-US"/>
+              <a:t>date of birth (P569) = [1848-03-18 (Prec.: day [-0 .. +0], PCal: Gregorian), 1848-01-01 (Prec.: year [-0 .. +0], PCal: Gregorian)]</a:t>
+            </a:r>
+          </a:p>
+          <a:p>
+            <a:pPr lvl="0"/>
+            <a:r>
+              <a:rPr lang="en-US"/>
+              <a:t>date of death (P570) = [1939-12-03 (Prec.: day [-0 .. +0], PCal: Gregorian), 1939-01-01 (Prec.: year [-0 .. +0], PCal: Gregorian)]</a:t>
+            </a:r>
+          </a:p>
+          <a:p>
+            <a:pPr lvl="0"/>
+            <a:r>
+              <a:rPr lang="en-US"/>
+              <a:t>place of birth (P19) = [http://www.wikidata.org/entity/Q42182 (item), http://www.wikidata.org/entity/Q84 (item)]</a:t>
+            </a:r>
+          </a:p>
+          <a:p>
+            <a:pPr lvl="0"/>
+            <a:r>
+              <a:rPr lang="en-US"/>
               <a:t>monogram (P1543) = Royal Monogram of Princess Louise of Great Britain.svg</a:t>
             </a:r>
           </a:p>
@@ -2480,7 +2550,14 @@
             <a:pPr lvl="0"/>
             <a:r>
               <a:rPr lang="en-US"/>
-              <a:t>place of death (P20) = London (Q84)</a:t>
+              <a:t>place of death (P20) = [http://www.wikidata.org/entity/Q207385 (item), http://www.wikidata.org/entity/Q84 (item)]</a:t>
+            </a:r>
+          </a:p>
+          <a:p>
+            <a:pPr lvl="0"/>
+            <a:r>
+              <a:rPr lang="en-US"/>
+              <a:t>signature (P109) = Signature of Princess Louise, Duchess of Argyll.svg</a:t>
             </a:r>
           </a:p>
           <a:p>
@@ -2495,27 +2572,6 @@
             <a:r>
               <a:rPr lang="en-US"/>
               <a:t>mother (P25) = Queen Victoria (Q9439)</a:t>
-            </a:r>
-          </a:p>
-          <a:p>
-            <a:pPr lvl="0"/>
-            <a:r>
-              <a:rPr lang="en-US"/>
-              <a:t>date of birth (P569) = 1848-04-18</a:t>
-            </a:r>
-          </a:p>
-          <a:p>
-            <a:pPr lvl="0"/>
-            <a:r>
-              <a:rPr lang="en-US"/>
-              <a:t>date of death (P570) = 1940-01-03</a:t>
-            </a:r>
-          </a:p>
-          <a:p>
-            <a:pPr lvl="0"/>
-            <a:r>
-              <a:rPr lang="en-US"/>
-              <a:t>place of birth (P19) = Buckingham Palace (Q42182)</a:t>
             </a:r>
           </a:p>
         </p:txBody>
@@ -2733,6 +2789,27 @@
             <a:pPr lvl="0"/>
             <a:r>
               <a:rPr lang="en-US"/>
+              <a:t>date of birth (P569) = 1850-05-01</a:t>
+            </a:r>
+          </a:p>
+          <a:p>
+            <a:pPr lvl="0"/>
+            <a:r>
+              <a:rPr lang="en-US"/>
+              <a:t>date of death (P570) = 1942-01-16</a:t>
+            </a:r>
+          </a:p>
+          <a:p>
+            <a:pPr lvl="0"/>
+            <a:r>
+              <a:rPr lang="en-US"/>
+              <a:t>place of birth (P19) = Buckingham Palace (Q42182)</a:t>
+            </a:r>
+          </a:p>
+          <a:p>
+            <a:pPr lvl="0"/>
+            <a:r>
+              <a:rPr lang="en-US"/>
               <a:t>sex or gender (P21) = male (Q6581097)</a:t>
             </a:r>
           </a:p>
@@ -2747,6 +2824,13 @@
             <a:pPr lvl="0"/>
             <a:r>
               <a:rPr lang="en-US"/>
+              <a:t>signature (P109) = Prince Arthur's signature.svg</a:t>
+            </a:r>
+          </a:p>
+          <a:p>
+            <a:pPr lvl="0"/>
+            <a:r>
+              <a:rPr lang="en-US"/>
               <a:t>father (P22) = Albert, Prince Consort (Q152245)</a:t>
             </a:r>
           </a:p>
@@ -2755,27 +2839,6 @@
             <a:r>
               <a:rPr lang="en-US"/>
               <a:t>mother (P25) = Queen Victoria (Q9439)</a:t>
-            </a:r>
-          </a:p>
-          <a:p>
-            <a:pPr lvl="0"/>
-            <a:r>
-              <a:rPr lang="en-US"/>
-              <a:t>date of birth (P569) = 1850-06-01</a:t>
-            </a:r>
-          </a:p>
-          <a:p>
-            <a:pPr lvl="0"/>
-            <a:r>
-              <a:rPr lang="en-US"/>
-              <a:t>date of death (P570) = 1942-02-16</a:t>
-            </a:r>
-          </a:p>
-          <a:p>
-            <a:pPr lvl="0"/>
-            <a:r>
-              <a:rPr lang="en-US"/>
-              <a:t>place of birth (P19) = Buckingham Palace (Q42182)</a:t>
             </a:r>
           </a:p>
         </p:txBody>
@@ -2993,13 +3056,6 @@
             <a:pPr lvl="0"/>
             <a:r>
               <a:rPr lang="en-US"/>
-              <a:t>date of birth (P569) = 1853-05-07</a:t>
-            </a:r>
-          </a:p>
-          <a:p>
-            <a:pPr lvl="0"/>
-            <a:r>
-              <a:rPr lang="en-US"/>
               <a:t>sex or gender (P21) = male (Q6581097)</a:t>
             </a:r>
           </a:p>
@@ -3014,6 +3070,13 @@
             <a:pPr lvl="0"/>
             <a:r>
               <a:rPr lang="en-US"/>
+              <a:t>signature (P109) = Prince Leopold's signature.svg</a:t>
+            </a:r>
+          </a:p>
+          <a:p>
+            <a:pPr lvl="0"/>
+            <a:r>
+              <a:rPr lang="en-US"/>
               <a:t>father (P22) = Albert, Prince Consort (Q152245)</a:t>
             </a:r>
           </a:p>
@@ -3028,7 +3091,14 @@
             <a:pPr lvl="0"/>
             <a:r>
               <a:rPr lang="en-US"/>
-              <a:t>date of death (P570) = 1884-04-28</a:t>
+              <a:t>date of birth (P569) = 1853-04-07</a:t>
+            </a:r>
+          </a:p>
+          <a:p>
+            <a:pPr lvl="0"/>
+            <a:r>
+              <a:rPr lang="en-US"/>
+              <a:t>date of death (P570) = 1884-03-28</a:t>
             </a:r>
           </a:p>
           <a:p>
@@ -6643,7 +6713,7 @@
                   <a:srgbClr val="0000FF"/>
                 </a:solidFill>
               </a:rPr>
-              <a:t>1819-06-24</a:t>
+              <a:t>1819-05-24</a:t>
             </a:r>
           </a:p>
         </p:txBody>
@@ -6803,7 +6873,7 @@
                   <a:srgbClr val="0000FF"/>
                 </a:solidFill>
               </a:rPr>
-              <a:t>1901-02-22</a:t>
+              <a:t>1901-01-22</a:t>
             </a:r>
           </a:p>
         </p:txBody>
@@ -7251,7 +7321,7 @@
         <p:spPr>
           <a:xfrm>
             <a:off x="254000" y="254000"/>
-            <a:ext cx="2540000" cy="3225800"/>
+            <a:ext cx="2540000" cy="3949700"/>
           </a:xfrm>
           <a:prstGeom prst="rect">
             <a:avLst/>
@@ -7413,7 +7483,7 @@
                   <a:srgbClr val="0000FF"/>
                 </a:solidFill>
               </a:rPr>
-              <a:t>Laszlo - Princess Henry of Battenberg.jpg</a:t>
+              <a:t>Princess Beatrice 1886.jpg</a:t>
             </a:r>
           </a:p>
         </p:txBody>
@@ -7733,7 +7803,7 @@
                   <a:srgbClr val="0000FF"/>
                 </a:solidFill>
               </a:rPr>
-              <a:t>1857-05-14</a:t>
+              <a:t>1857-04-14</a:t>
             </a:r>
           </a:p>
         </p:txBody>
@@ -7893,7 +7963,7 @@
                   <a:srgbClr val="0000FF"/>
                 </a:solidFill>
               </a:rPr>
-              <a:t>1944-11-26</a:t>
+              <a:t>1944-10-26</a:t>
             </a:r>
           </a:p>
         </p:txBody>
@@ -8823,7 +8893,7 @@
                   <a:srgbClr val="0000FF"/>
                 </a:solidFill>
               </a:rPr>
-              <a:t>1840-12-21</a:t>
+              <a:t>1840-11-21</a:t>
             </a:r>
           </a:p>
         </p:txBody>
@@ -8903,7 +8973,7 @@
                   <a:srgbClr val="0000FF"/>
                 </a:solidFill>
               </a:rPr>
-              <a:t>1901-09-05</a:t>
+              <a:t>1901-08-05</a:t>
             </a:r>
           </a:p>
         </p:txBody>
@@ -9351,7 +9421,7 @@
         <p:spPr>
           <a:xfrm>
             <a:off x="254000" y="254000"/>
-            <a:ext cx="2540000" cy="3581400"/>
+            <a:ext cx="2540000" cy="3949700"/>
           </a:xfrm>
           <a:prstGeom prst="rect">
             <a:avLst/>
@@ -9513,7 +9583,7 @@
                   <a:srgbClr val="0000FF"/>
                 </a:solidFill>
               </a:rPr>
-              <a:t>Edward VII in coronation robes.jpg</a:t>
+              <a:t>King-Edward-VII (cropped).jpg</a:t>
             </a:r>
           </a:p>
         </p:txBody>
@@ -9833,7 +9903,7 @@
                   <a:srgbClr val="0000FF"/>
                 </a:solidFill>
               </a:rPr>
-              <a:t>1841-12-09</a:t>
+              <a:t>1841-11-09</a:t>
             </a:r>
           </a:p>
         </p:txBody>
@@ -9993,7 +10063,7 @@
                   <a:srgbClr val="0000FF"/>
                 </a:solidFill>
               </a:rPr>
-              <a:t>1910-06-06</a:t>
+              <a:t>1910-05-06</a:t>
             </a:r>
           </a:p>
         </p:txBody>
@@ -10441,7 +10511,7 @@
         <p:spPr>
           <a:xfrm>
             <a:off x="254000" y="254000"/>
-            <a:ext cx="2540000" cy="3378200"/>
+            <a:ext cx="2540000" cy="3746500"/>
           </a:xfrm>
           <a:prstGeom prst="rect">
             <a:avLst/>
@@ -10603,7 +10673,7 @@
                   <a:srgbClr val="0000FF"/>
                 </a:solidFill>
               </a:rPr>
-              <a:t>Princess Alice 1861.png</a:t>
+              <a:t>Alice, Princess Louis of Hesse.jpg</a:t>
             </a:r>
           </a:p>
         </p:txBody>
@@ -10923,7 +10993,7 @@
                   <a:srgbClr val="0000FF"/>
                 </a:solidFill>
               </a:rPr>
-              <a:t>1843-05-25</a:t>
+              <a:t>1843-04-25</a:t>
             </a:r>
           </a:p>
         </p:txBody>
@@ -11003,7 +11073,7 @@
                   <a:srgbClr val="0000FF"/>
                 </a:solidFill>
               </a:rPr>
-              <a:t>London (Q84)</a:t>
+              <a:t>Buckingham Palace (Q42182)</a:t>
             </a:r>
           </a:p>
         </p:txBody>
@@ -11083,7 +11153,7 @@
                   <a:srgbClr val="0000FF"/>
                 </a:solidFill>
               </a:rPr>
-              <a:t>1879-01-14</a:t>
+              <a:t>1878-12-14</a:t>
             </a:r>
           </a:p>
         </p:txBody>
@@ -11509,7 +11579,7 @@
                 </a:solidFill>
                 <a:hlinkClick r:id="rId2" tooltip="https://tools.wmflabs.org/sqid/#/view?id=Q158143"/>
               </a:rPr>
-              <a:t>Alfred</a:t>
+              <a:t>Alfred, Duke of Saxe-Coburg and Gotha</a:t>
             </a:r>
           </a:p>
         </p:txBody>
@@ -11531,7 +11601,7 @@
         <p:spPr>
           <a:xfrm>
             <a:off x="254000" y="254000"/>
-            <a:ext cx="2540000" cy="3822700"/>
+            <a:ext cx="2540000" cy="3251200"/>
           </a:xfrm>
           <a:prstGeom prst="rect">
             <a:avLst/>
@@ -11693,7 +11763,7 @@
                   <a:srgbClr val="0000FF"/>
                 </a:solidFill>
               </a:rPr>
-              <a:t>Alfred-sachsen-coburg-gotha.jpg</a:t>
+              <a:t>Alfred duke of Edinburgh.jpg</a:t>
             </a:r>
           </a:p>
         </p:txBody>
@@ -12013,7 +12083,7 @@
                   <a:srgbClr val="0000FF"/>
                 </a:solidFill>
               </a:rPr>
-              <a:t>1844-09-06</a:t>
+              <a:t>1844-08-06</a:t>
             </a:r>
           </a:p>
         </p:txBody>
@@ -12133,7 +12203,7 @@
                   <a:srgbClr val="000000"/>
                 </a:solidFill>
               </a:rPr>
-              <a:t>date of death:</a:t>
+              <a:t>place of death:</a:t>
             </a:r>
           </a:p>
         </p:txBody>
@@ -12173,7 +12243,7 @@
                   <a:srgbClr val="0000FF"/>
                 </a:solidFill>
               </a:rPr>
-              <a:t>1900-08-30</a:t>
+              <a:t>Schloss Rosenau (Q449510)</a:t>
             </a:r>
           </a:p>
         </p:txBody>
@@ -12213,7 +12283,7 @@
                   <a:srgbClr val="000000"/>
                 </a:solidFill>
               </a:rPr>
-              <a:t>place of death:</a:t>
+              <a:t>wiki_en:</a:t>
             </a:r>
           </a:p>
         </p:txBody>
@@ -12253,7 +12323,7 @@
                   <a:srgbClr val="0000FF"/>
                 </a:solidFill>
               </a:rPr>
-              <a:t>Schloss Rosenau (Q449510)</a:t>
+              <a:t>Alfred, Duke of Saxe-Coburg and Gotha</a:t>
             </a:r>
           </a:p>
         </p:txBody>
@@ -12293,7 +12363,7 @@
                   <a:srgbClr val="000000"/>
                 </a:solidFill>
               </a:rPr>
-              <a:t>wiki_en:</a:t>
+              <a:t>label_en:</a:t>
             </a:r>
           </a:p>
         </p:txBody>
@@ -12373,7 +12443,7 @@
                   <a:srgbClr val="000000"/>
                 </a:solidFill>
               </a:rPr>
-              <a:t>label_en:</a:t>
+              <a:t>source:</a:t>
             </a:r>
           </a:p>
         </p:txBody>
@@ -12387,86 +12457,6 @@
         <p:spPr>
           <a:xfrm>
             <a:off x="4445000" y="3606800"/>
-            <a:ext cx="4445000" cy="304800"/>
-          </a:xfrm>
-          <a:prstGeom prst="rect">
-            <a:avLst/>
-          </a:prstGeom>
-        </p:spPr>
-        <p:txBody>
-          <a:bodyPr anchor="t" rtlCol="false"/>
-          <a:lstStyle/>
-          <a:p>
-            <a:pPr algn="l">
-              <a:defRPr/>
-            </a:pPr>
-            <a:r>
-              <a:rPr lang="de-DE"/>
-              <a:t/>
-            </a:r>
-            <a:endParaRPr lang="en-US" sz="1100"/>
-          </a:p>
-          <a:p>
-            <a:r>
-              <a:rPr lang="en-US" sz="1600">
-                <a:solidFill>
-                  <a:srgbClr val="0000FF"/>
-                </a:solidFill>
-              </a:rPr>
-              <a:t>Alfred</a:t>
-            </a:r>
-          </a:p>
-        </p:txBody>
-      </p:sp>
-      <p:sp>
-        <p:nvSpPr>
-          <p:cNvPr name="TextBox 27" id="27"/>
-          <p:cNvSpPr txBox="true"/>
-          <p:nvPr/>
-        </p:nvSpPr>
-        <p:spPr>
-          <a:xfrm>
-            <a:off x="2984500" y="3911600"/>
-            <a:ext cx="1460500" cy="304800"/>
-          </a:xfrm>
-          <a:prstGeom prst="rect">
-            <a:avLst/>
-          </a:prstGeom>
-        </p:spPr>
-        <p:txBody>
-          <a:bodyPr anchor="t" rtlCol="false"/>
-          <a:lstStyle/>
-          <a:p>
-            <a:pPr algn="l">
-              <a:defRPr/>
-            </a:pPr>
-            <a:r>
-              <a:rPr lang="de-DE"/>
-              <a:t/>
-            </a:r>
-            <a:endParaRPr lang="en-US" sz="1100"/>
-          </a:p>
-          <a:p>
-            <a:r>
-              <a:rPr lang="en-US" sz="1600">
-                <a:solidFill>
-                  <a:srgbClr val="000000"/>
-                </a:solidFill>
-              </a:rPr>
-              <a:t>source:</a:t>
-            </a:r>
-          </a:p>
-        </p:txBody>
-      </p:sp>
-      <p:sp>
-        <p:nvSpPr>
-          <p:cNvPr name="TextBox 28" id="28"/>
-          <p:cNvSpPr txBox="true"/>
-          <p:nvPr/>
-        </p:nvSpPr>
-        <p:spPr>
-          <a:xfrm>
-            <a:off x="4445000" y="3911600"/>
             <a:ext cx="4445000" cy="304800"/>
           </a:xfrm>
           <a:prstGeom prst="rect">
@@ -12621,7 +12611,7 @@
         <p:spPr>
           <a:xfrm>
             <a:off x="254000" y="254000"/>
-            <a:ext cx="2540000" cy="3568700"/>
+            <a:ext cx="2540000" cy="3378200"/>
           </a:xfrm>
           <a:prstGeom prst="rect">
             <a:avLst/>
@@ -12783,7 +12773,7 @@
                   <a:srgbClr val="0000FF"/>
                 </a:solidFill>
               </a:rPr>
-              <a:t>Princess Helena Augusta Victoria of Schleswig-Holstein.jpg</a:t>
+              <a:t>Helena, Princess Christian of Schleswig-Holstein, 1887.jpg</a:t>
             </a:r>
           </a:p>
         </p:txBody>
@@ -13143,7 +13133,7 @@
                   <a:srgbClr val="000000"/>
                 </a:solidFill>
               </a:rPr>
-              <a:t>date of death:</a:t>
+              <a:t>place of death:</a:t>
             </a:r>
           </a:p>
         </p:txBody>
@@ -13183,7 +13173,7 @@
                   <a:srgbClr val="0000FF"/>
                 </a:solidFill>
               </a:rPr>
-              <a:t>1923-07-09</a:t>
+              <a:t>Schomberg House (Q7432105)</a:t>
             </a:r>
           </a:p>
         </p:txBody>
@@ -13223,7 +13213,7 @@
                   <a:srgbClr val="000000"/>
                 </a:solidFill>
               </a:rPr>
-              <a:t>place of death:</a:t>
+              <a:t>wiki_en:</a:t>
             </a:r>
           </a:p>
         </p:txBody>
@@ -13263,7 +13253,7 @@
                   <a:srgbClr val="0000FF"/>
                 </a:solidFill>
               </a:rPr>
-              <a:t>London (Q84)</a:t>
+              <a:t>Princess Helena of the United Kingdom</a:t>
             </a:r>
           </a:p>
         </p:txBody>
@@ -13303,7 +13293,7 @@
                   <a:srgbClr val="000000"/>
                 </a:solidFill>
               </a:rPr>
-              <a:t>wiki_en:</a:t>
+              <a:t>label_en:</a:t>
             </a:r>
           </a:p>
         </p:txBody>
@@ -13383,7 +13373,7 @@
                   <a:srgbClr val="000000"/>
                 </a:solidFill>
               </a:rPr>
-              <a:t>label_en:</a:t>
+              <a:t>source:</a:t>
             </a:r>
           </a:p>
         </p:txBody>
@@ -13397,86 +13387,6 @@
         <p:spPr>
           <a:xfrm>
             <a:off x="4445000" y="3302000"/>
-            <a:ext cx="4445000" cy="304800"/>
-          </a:xfrm>
-          <a:prstGeom prst="rect">
-            <a:avLst/>
-          </a:prstGeom>
-        </p:spPr>
-        <p:txBody>
-          <a:bodyPr anchor="t" rtlCol="false"/>
-          <a:lstStyle/>
-          <a:p>
-            <a:pPr algn="l">
-              <a:defRPr/>
-            </a:pPr>
-            <a:r>
-              <a:rPr lang="de-DE"/>
-              <a:t/>
-            </a:r>
-            <a:endParaRPr lang="en-US" sz="1100"/>
-          </a:p>
-          <a:p>
-            <a:r>
-              <a:rPr lang="en-US" sz="1600">
-                <a:solidFill>
-                  <a:srgbClr val="0000FF"/>
-                </a:solidFill>
-              </a:rPr>
-              <a:t>Princess Helena of the United Kingdom</a:t>
-            </a:r>
-          </a:p>
-        </p:txBody>
-      </p:sp>
-      <p:sp>
-        <p:nvSpPr>
-          <p:cNvPr name="TextBox 25" id="25"/>
-          <p:cNvSpPr txBox="true"/>
-          <p:nvPr/>
-        </p:nvSpPr>
-        <p:spPr>
-          <a:xfrm>
-            <a:off x="2984500" y="3606800"/>
-            <a:ext cx="1460500" cy="304800"/>
-          </a:xfrm>
-          <a:prstGeom prst="rect">
-            <a:avLst/>
-          </a:prstGeom>
-        </p:spPr>
-        <p:txBody>
-          <a:bodyPr anchor="t" rtlCol="false"/>
-          <a:lstStyle/>
-          <a:p>
-            <a:pPr algn="l">
-              <a:defRPr/>
-            </a:pPr>
-            <a:r>
-              <a:rPr lang="de-DE"/>
-              <a:t/>
-            </a:r>
-            <a:endParaRPr lang="en-US" sz="1100"/>
-          </a:p>
-          <a:p>
-            <a:r>
-              <a:rPr lang="en-US" sz="1600">
-                <a:solidFill>
-                  <a:srgbClr val="000000"/>
-                </a:solidFill>
-              </a:rPr>
-              <a:t>source:</a:t>
-            </a:r>
-          </a:p>
-        </p:txBody>
-      </p:sp>
-      <p:sp>
-        <p:nvSpPr>
-          <p:cNvPr name="TextBox 26" id="26"/>
-          <p:cNvSpPr txBox="true"/>
-          <p:nvPr/>
-        </p:nvSpPr>
-        <p:spPr>
-          <a:xfrm>
-            <a:off x="4445000" y="3606800"/>
             <a:ext cx="4445000" cy="304800"/>
           </a:xfrm>
           <a:prstGeom prst="rect">
@@ -13631,7 +13541,7 @@
         <p:spPr>
           <a:xfrm>
             <a:off x="254000" y="254000"/>
-            <a:ext cx="2540000" cy="3708400"/>
+            <a:ext cx="2540000" cy="3810000"/>
           </a:xfrm>
           <a:prstGeom prst="rect">
             <a:avLst/>
@@ -13793,7 +13703,7 @@
                   <a:srgbClr val="0000FF"/>
                 </a:solidFill>
               </a:rPr>
-              <a:t>Princess Louise 1901 copy.jpg</a:t>
+              <a:t>Princess Louise 1881.png</a:t>
             </a:r>
           </a:p>
         </p:txBody>
@@ -14073,7 +13983,7 @@
                   <a:srgbClr val="000000"/>
                 </a:solidFill>
               </a:rPr>
-              <a:t>date of birth:</a:t>
+              <a:t>wiki_en:</a:t>
             </a:r>
           </a:p>
         </p:txBody>
@@ -14113,7 +14023,7 @@
                   <a:srgbClr val="0000FF"/>
                 </a:solidFill>
               </a:rPr>
-              <a:t>1848-04-18</a:t>
+              <a:t>Princess Louise, Duchess of Argyll</a:t>
             </a:r>
           </a:p>
         </p:txBody>
@@ -14153,7 +14063,7 @@
                   <a:srgbClr val="000000"/>
                 </a:solidFill>
               </a:rPr>
-              <a:t>place of birth:</a:t>
+              <a:t>label_en:</a:t>
             </a:r>
           </a:p>
         </p:txBody>
@@ -14193,7 +14103,7 @@
                   <a:srgbClr val="0000FF"/>
                 </a:solidFill>
               </a:rPr>
-              <a:t>Buckingham Palace (Q42182)</a:t>
+              <a:t>Princess Louise, Duchess of Argyll</a:t>
             </a:r>
           </a:p>
         </p:txBody>
@@ -14233,7 +14143,7 @@
                   <a:srgbClr val="000000"/>
                 </a:solidFill>
               </a:rPr>
-              <a:t>date of death:</a:t>
+              <a:t>source:</a:t>
             </a:r>
           </a:p>
         </p:txBody>
@@ -14247,326 +14157,6 @@
         <p:spPr>
           <a:xfrm>
             <a:off x="4445000" y="2692400"/>
-            <a:ext cx="4445000" cy="304800"/>
-          </a:xfrm>
-          <a:prstGeom prst="rect">
-            <a:avLst/>
-          </a:prstGeom>
-        </p:spPr>
-        <p:txBody>
-          <a:bodyPr anchor="t" rtlCol="false"/>
-          <a:lstStyle/>
-          <a:p>
-            <a:pPr algn="l">
-              <a:defRPr/>
-            </a:pPr>
-            <a:r>
-              <a:rPr lang="de-DE"/>
-              <a:t/>
-            </a:r>
-            <a:endParaRPr lang="en-US" sz="1100"/>
-          </a:p>
-          <a:p>
-            <a:r>
-              <a:rPr lang="en-US" sz="1600">
-                <a:solidFill>
-                  <a:srgbClr val="0000FF"/>
-                </a:solidFill>
-              </a:rPr>
-              <a:t>1940-01-03</a:t>
-            </a:r>
-          </a:p>
-        </p:txBody>
-      </p:sp>
-      <p:sp>
-        <p:nvSpPr>
-          <p:cNvPr name="TextBox 21" id="21"/>
-          <p:cNvSpPr txBox="true"/>
-          <p:nvPr/>
-        </p:nvSpPr>
-        <p:spPr>
-          <a:xfrm>
-            <a:off x="2984500" y="2997200"/>
-            <a:ext cx="1460500" cy="304800"/>
-          </a:xfrm>
-          <a:prstGeom prst="rect">
-            <a:avLst/>
-          </a:prstGeom>
-        </p:spPr>
-        <p:txBody>
-          <a:bodyPr anchor="t" rtlCol="false"/>
-          <a:lstStyle/>
-          <a:p>
-            <a:pPr algn="l">
-              <a:defRPr/>
-            </a:pPr>
-            <a:r>
-              <a:rPr lang="de-DE"/>
-              <a:t/>
-            </a:r>
-            <a:endParaRPr lang="en-US" sz="1100"/>
-          </a:p>
-          <a:p>
-            <a:r>
-              <a:rPr lang="en-US" sz="1600">
-                <a:solidFill>
-                  <a:srgbClr val="000000"/>
-                </a:solidFill>
-              </a:rPr>
-              <a:t>place of death:</a:t>
-            </a:r>
-          </a:p>
-        </p:txBody>
-      </p:sp>
-      <p:sp>
-        <p:nvSpPr>
-          <p:cNvPr name="TextBox 22" id="22"/>
-          <p:cNvSpPr txBox="true"/>
-          <p:nvPr/>
-        </p:nvSpPr>
-        <p:spPr>
-          <a:xfrm>
-            <a:off x="4445000" y="2997200"/>
-            <a:ext cx="4445000" cy="304800"/>
-          </a:xfrm>
-          <a:prstGeom prst="rect">
-            <a:avLst/>
-          </a:prstGeom>
-        </p:spPr>
-        <p:txBody>
-          <a:bodyPr anchor="t" rtlCol="false"/>
-          <a:lstStyle/>
-          <a:p>
-            <a:pPr algn="l">
-              <a:defRPr/>
-            </a:pPr>
-            <a:r>
-              <a:rPr lang="de-DE"/>
-              <a:t/>
-            </a:r>
-            <a:endParaRPr lang="en-US" sz="1100"/>
-          </a:p>
-          <a:p>
-            <a:r>
-              <a:rPr lang="en-US" sz="1600">
-                <a:solidFill>
-                  <a:srgbClr val="0000FF"/>
-                </a:solidFill>
-              </a:rPr>
-              <a:t>London (Q84)</a:t>
-            </a:r>
-          </a:p>
-        </p:txBody>
-      </p:sp>
-      <p:sp>
-        <p:nvSpPr>
-          <p:cNvPr name="TextBox 23" id="23"/>
-          <p:cNvSpPr txBox="true"/>
-          <p:nvPr/>
-        </p:nvSpPr>
-        <p:spPr>
-          <a:xfrm>
-            <a:off x="2984500" y="3302000"/>
-            <a:ext cx="1460500" cy="304800"/>
-          </a:xfrm>
-          <a:prstGeom prst="rect">
-            <a:avLst/>
-          </a:prstGeom>
-        </p:spPr>
-        <p:txBody>
-          <a:bodyPr anchor="t" rtlCol="false"/>
-          <a:lstStyle/>
-          <a:p>
-            <a:pPr algn="l">
-              <a:defRPr/>
-            </a:pPr>
-            <a:r>
-              <a:rPr lang="de-DE"/>
-              <a:t/>
-            </a:r>
-            <a:endParaRPr lang="en-US" sz="1100"/>
-          </a:p>
-          <a:p>
-            <a:r>
-              <a:rPr lang="en-US" sz="1600">
-                <a:solidFill>
-                  <a:srgbClr val="000000"/>
-                </a:solidFill>
-              </a:rPr>
-              <a:t>wiki_en:</a:t>
-            </a:r>
-          </a:p>
-        </p:txBody>
-      </p:sp>
-      <p:sp>
-        <p:nvSpPr>
-          <p:cNvPr name="TextBox 24" id="24"/>
-          <p:cNvSpPr txBox="true"/>
-          <p:nvPr/>
-        </p:nvSpPr>
-        <p:spPr>
-          <a:xfrm>
-            <a:off x="4445000" y="3302000"/>
-            <a:ext cx="4445000" cy="304800"/>
-          </a:xfrm>
-          <a:prstGeom prst="rect">
-            <a:avLst/>
-          </a:prstGeom>
-        </p:spPr>
-        <p:txBody>
-          <a:bodyPr anchor="t" rtlCol="false"/>
-          <a:lstStyle/>
-          <a:p>
-            <a:pPr algn="l">
-              <a:defRPr/>
-            </a:pPr>
-            <a:r>
-              <a:rPr lang="de-DE"/>
-              <a:t/>
-            </a:r>
-            <a:endParaRPr lang="en-US" sz="1100"/>
-          </a:p>
-          <a:p>
-            <a:r>
-              <a:rPr lang="en-US" sz="1600">
-                <a:solidFill>
-                  <a:srgbClr val="0000FF"/>
-                </a:solidFill>
-              </a:rPr>
-              <a:t>Princess Louise, Duchess of Argyll</a:t>
-            </a:r>
-          </a:p>
-        </p:txBody>
-      </p:sp>
-      <p:sp>
-        <p:nvSpPr>
-          <p:cNvPr name="TextBox 25" id="25"/>
-          <p:cNvSpPr txBox="true"/>
-          <p:nvPr/>
-        </p:nvSpPr>
-        <p:spPr>
-          <a:xfrm>
-            <a:off x="2984500" y="3606800"/>
-            <a:ext cx="1460500" cy="304800"/>
-          </a:xfrm>
-          <a:prstGeom prst="rect">
-            <a:avLst/>
-          </a:prstGeom>
-        </p:spPr>
-        <p:txBody>
-          <a:bodyPr anchor="t" rtlCol="false"/>
-          <a:lstStyle/>
-          <a:p>
-            <a:pPr algn="l">
-              <a:defRPr/>
-            </a:pPr>
-            <a:r>
-              <a:rPr lang="de-DE"/>
-              <a:t/>
-            </a:r>
-            <a:endParaRPr lang="en-US" sz="1100"/>
-          </a:p>
-          <a:p>
-            <a:r>
-              <a:rPr lang="en-US" sz="1600">
-                <a:solidFill>
-                  <a:srgbClr val="000000"/>
-                </a:solidFill>
-              </a:rPr>
-              <a:t>label_en:</a:t>
-            </a:r>
-          </a:p>
-        </p:txBody>
-      </p:sp>
-      <p:sp>
-        <p:nvSpPr>
-          <p:cNvPr name="TextBox 26" id="26"/>
-          <p:cNvSpPr txBox="true"/>
-          <p:nvPr/>
-        </p:nvSpPr>
-        <p:spPr>
-          <a:xfrm>
-            <a:off x="4445000" y="3606800"/>
-            <a:ext cx="4445000" cy="304800"/>
-          </a:xfrm>
-          <a:prstGeom prst="rect">
-            <a:avLst/>
-          </a:prstGeom>
-        </p:spPr>
-        <p:txBody>
-          <a:bodyPr anchor="t" rtlCol="false"/>
-          <a:lstStyle/>
-          <a:p>
-            <a:pPr algn="l">
-              <a:defRPr/>
-            </a:pPr>
-            <a:r>
-              <a:rPr lang="de-DE"/>
-              <a:t/>
-            </a:r>
-            <a:endParaRPr lang="en-US" sz="1100"/>
-          </a:p>
-          <a:p>
-            <a:r>
-              <a:rPr lang="en-US" sz="1600">
-                <a:solidFill>
-                  <a:srgbClr val="0000FF"/>
-                </a:solidFill>
-              </a:rPr>
-              <a:t>Princess Louise, Duchess of Argyll</a:t>
-            </a:r>
-          </a:p>
-        </p:txBody>
-      </p:sp>
-      <p:sp>
-        <p:nvSpPr>
-          <p:cNvPr name="TextBox 27" id="27"/>
-          <p:cNvSpPr txBox="true"/>
-          <p:nvPr/>
-        </p:nvSpPr>
-        <p:spPr>
-          <a:xfrm>
-            <a:off x="2984500" y="3911600"/>
-            <a:ext cx="1460500" cy="304800"/>
-          </a:xfrm>
-          <a:prstGeom prst="rect">
-            <a:avLst/>
-          </a:prstGeom>
-        </p:spPr>
-        <p:txBody>
-          <a:bodyPr anchor="t" rtlCol="false"/>
-          <a:lstStyle/>
-          <a:p>
-            <a:pPr algn="l">
-              <a:defRPr/>
-            </a:pPr>
-            <a:r>
-              <a:rPr lang="de-DE"/>
-              <a:t/>
-            </a:r>
-            <a:endParaRPr lang="en-US" sz="1100"/>
-          </a:p>
-          <a:p>
-            <a:r>
-              <a:rPr lang="en-US" sz="1600">
-                <a:solidFill>
-                  <a:srgbClr val="000000"/>
-                </a:solidFill>
-              </a:rPr>
-              <a:t>source:</a:t>
-            </a:r>
-          </a:p>
-        </p:txBody>
-      </p:sp>
-      <p:sp>
-        <p:nvSpPr>
-          <p:cNvPr name="TextBox 28" id="28"/>
-          <p:cNvSpPr txBox="true"/>
-          <p:nvPr/>
-        </p:nvSpPr>
-        <p:spPr>
-          <a:xfrm>
-            <a:off x="4445000" y="3911600"/>
             <a:ext cx="4445000" cy="304800"/>
           </a:xfrm>
           <a:prstGeom prst="rect">
@@ -14704,9 +14294,33 @@
           </a:p>
         </p:txBody>
       </p:sp>
-      <p:sp>
-        <p:nvSpPr>
-          <p:cNvPr name="TextBox 4" id="4"/>
+      <p:pic>
+        <p:nvPicPr>
+          <p:cNvPr name="Picture 4" id="4"/>
+          <p:cNvPicPr>
+            <a:picLocks noChangeAspect="true"/>
+          </p:cNvPicPr>
+          <p:nvPr/>
+        </p:nvPicPr>
+        <p:blipFill>
+          <a:blip r:embed="rId3"/>
+          <a:stretch>
+            <a:fillRect/>
+          </a:stretch>
+        </p:blipFill>
+        <p:spPr>
+          <a:xfrm>
+            <a:off x="254000" y="254000"/>
+            <a:ext cx="2540000" cy="3467100"/>
+          </a:xfrm>
+          <a:prstGeom prst="rect">
+            <a:avLst/>
+          </a:prstGeom>
+        </p:spPr>
+      </p:pic>
+      <p:sp>
+        <p:nvSpPr>
+          <p:cNvPr name="TextBox 5" id="5"/>
           <p:cNvSpPr txBox="true"/>
           <p:nvPr/>
         </p:nvSpPr>
@@ -14746,7 +14360,7 @@
       </p:sp>
       <p:sp>
         <p:nvSpPr>
-          <p:cNvPr name="TextBox 5" id="5"/>
+          <p:cNvPr name="TextBox 6" id="6"/>
           <p:cNvSpPr txBox="true"/>
           <p:nvPr/>
         </p:nvSpPr>
@@ -14786,7 +14400,7 @@
       </p:sp>
       <p:sp>
         <p:nvSpPr>
-          <p:cNvPr name="TextBox 6" id="6"/>
+          <p:cNvPr name="TextBox 7" id="7"/>
           <p:cNvSpPr txBox="true"/>
           <p:nvPr/>
         </p:nvSpPr>
@@ -14819,14 +14433,14 @@
                   <a:srgbClr val="000000"/>
                 </a:solidFill>
               </a:rPr>
-              <a:t>sex or gender:</a:t>
-            </a:r>
-          </a:p>
-        </p:txBody>
-      </p:sp>
-      <p:sp>
-        <p:nvSpPr>
-          <p:cNvPr name="TextBox 7" id="7"/>
+              <a:t>image:</a:t>
+            </a:r>
+          </a:p>
+        </p:txBody>
+      </p:sp>
+      <p:sp>
+        <p:nvSpPr>
+          <p:cNvPr name="TextBox 8" id="8"/>
           <p:cNvSpPr txBox="true"/>
           <p:nvPr/>
         </p:nvSpPr>
@@ -14854,19 +14468,19 @@
           </a:p>
           <a:p>
             <a:r>
-              <a:rPr lang="en-US" sz="1600">
+              <a:rPr lang="en-US" sz="1200">
                 <a:solidFill>
                   <a:srgbClr val="0000FF"/>
                 </a:solidFill>
               </a:rPr>
-              <a:t>male (Q6581097)</a:t>
-            </a:r>
-          </a:p>
-        </p:txBody>
-      </p:sp>
-      <p:sp>
-        <p:nvSpPr>
-          <p:cNvPr name="TextBox 8" id="8"/>
+              <a:t>Prince Arthur, 1st Duke of Connaught and Strathearn.jpg</a:t>
+            </a:r>
+          </a:p>
+        </p:txBody>
+      </p:sp>
+      <p:sp>
+        <p:nvSpPr>
+          <p:cNvPr name="TextBox 9" id="9"/>
           <p:cNvSpPr txBox="true"/>
           <p:nvPr/>
         </p:nvSpPr>
@@ -14899,14 +14513,14 @@
                   <a:srgbClr val="000000"/>
                 </a:solidFill>
               </a:rPr>
-              <a:t>father:</a:t>
-            </a:r>
-          </a:p>
-        </p:txBody>
-      </p:sp>
-      <p:sp>
-        <p:nvSpPr>
-          <p:cNvPr name="TextBox 9" id="9"/>
+              <a:t>sex or gender:</a:t>
+            </a:r>
+          </a:p>
+        </p:txBody>
+      </p:sp>
+      <p:sp>
+        <p:nvSpPr>
+          <p:cNvPr name="TextBox 10" id="10"/>
           <p:cNvSpPr txBox="true"/>
           <p:nvPr/>
         </p:nvSpPr>
@@ -14939,14 +14553,14 @@
                   <a:srgbClr val="0000FF"/>
                 </a:solidFill>
               </a:rPr>
-              <a:t>Albert, Prince Consort (Q152245)</a:t>
-            </a:r>
-          </a:p>
-        </p:txBody>
-      </p:sp>
-      <p:sp>
-        <p:nvSpPr>
-          <p:cNvPr name="TextBox 10" id="10"/>
+              <a:t>male (Q6581097)</a:t>
+            </a:r>
+          </a:p>
+        </p:txBody>
+      </p:sp>
+      <p:sp>
+        <p:nvSpPr>
+          <p:cNvPr name="TextBox 11" id="11"/>
           <p:cNvSpPr txBox="true"/>
           <p:nvPr/>
         </p:nvSpPr>
@@ -14979,14 +14593,14 @@
                   <a:srgbClr val="000000"/>
                 </a:solidFill>
               </a:rPr>
-              <a:t>mother:</a:t>
-            </a:r>
-          </a:p>
-        </p:txBody>
-      </p:sp>
-      <p:sp>
-        <p:nvSpPr>
-          <p:cNvPr name="TextBox 11" id="11"/>
+              <a:t>father:</a:t>
+            </a:r>
+          </a:p>
+        </p:txBody>
+      </p:sp>
+      <p:sp>
+        <p:nvSpPr>
+          <p:cNvPr name="TextBox 12" id="12"/>
           <p:cNvSpPr txBox="true"/>
           <p:nvPr/>
         </p:nvSpPr>
@@ -15019,14 +14633,14 @@
                   <a:srgbClr val="0000FF"/>
                 </a:solidFill>
               </a:rPr>
-              <a:t>Queen Victoria (Q9439)</a:t>
-            </a:r>
-          </a:p>
-        </p:txBody>
-      </p:sp>
-      <p:sp>
-        <p:nvSpPr>
-          <p:cNvPr name="TextBox 12" id="12"/>
+              <a:t>Albert, Prince Consort (Q152245)</a:t>
+            </a:r>
+          </a:p>
+        </p:txBody>
+      </p:sp>
+      <p:sp>
+        <p:nvSpPr>
+          <p:cNvPr name="TextBox 13" id="13"/>
           <p:cNvSpPr txBox="true"/>
           <p:nvPr/>
         </p:nvSpPr>
@@ -15059,14 +14673,14 @@
                   <a:srgbClr val="000000"/>
                 </a:solidFill>
               </a:rPr>
-              <a:t>date of birth:</a:t>
-            </a:r>
-          </a:p>
-        </p:txBody>
-      </p:sp>
-      <p:sp>
-        <p:nvSpPr>
-          <p:cNvPr name="TextBox 13" id="13"/>
+              <a:t>mother:</a:t>
+            </a:r>
+          </a:p>
+        </p:txBody>
+      </p:sp>
+      <p:sp>
+        <p:nvSpPr>
+          <p:cNvPr name="TextBox 14" id="14"/>
           <p:cNvSpPr txBox="true"/>
           <p:nvPr/>
         </p:nvSpPr>
@@ -15099,14 +14713,14 @@
                   <a:srgbClr val="0000FF"/>
                 </a:solidFill>
               </a:rPr>
-              <a:t>1850-06-01</a:t>
-            </a:r>
-          </a:p>
-        </p:txBody>
-      </p:sp>
-      <p:sp>
-        <p:nvSpPr>
-          <p:cNvPr name="TextBox 14" id="14"/>
+              <a:t>Queen Victoria (Q9439)</a:t>
+            </a:r>
+          </a:p>
+        </p:txBody>
+      </p:sp>
+      <p:sp>
+        <p:nvSpPr>
+          <p:cNvPr name="TextBox 15" id="15"/>
           <p:cNvSpPr txBox="true"/>
           <p:nvPr/>
         </p:nvSpPr>
@@ -15139,14 +14753,14 @@
                   <a:srgbClr val="000000"/>
                 </a:solidFill>
               </a:rPr>
-              <a:t>place of birth:</a:t>
-            </a:r>
-          </a:p>
-        </p:txBody>
-      </p:sp>
-      <p:sp>
-        <p:nvSpPr>
-          <p:cNvPr name="TextBox 15" id="15"/>
+              <a:t>date of birth:</a:t>
+            </a:r>
+          </a:p>
+        </p:txBody>
+      </p:sp>
+      <p:sp>
+        <p:nvSpPr>
+          <p:cNvPr name="TextBox 16" id="16"/>
           <p:cNvSpPr txBox="true"/>
           <p:nvPr/>
         </p:nvSpPr>
@@ -15179,14 +14793,14 @@
                   <a:srgbClr val="0000FF"/>
                 </a:solidFill>
               </a:rPr>
-              <a:t>Buckingham Palace (Q42182)</a:t>
-            </a:r>
-          </a:p>
-        </p:txBody>
-      </p:sp>
-      <p:sp>
-        <p:nvSpPr>
-          <p:cNvPr name="TextBox 16" id="16"/>
+              <a:t>1850-05-01</a:t>
+            </a:r>
+          </a:p>
+        </p:txBody>
+      </p:sp>
+      <p:sp>
+        <p:nvSpPr>
+          <p:cNvPr name="TextBox 17" id="17"/>
           <p:cNvSpPr txBox="true"/>
           <p:nvPr/>
         </p:nvSpPr>
@@ -15219,14 +14833,14 @@
                   <a:srgbClr val="000000"/>
                 </a:solidFill>
               </a:rPr>
-              <a:t>date of death:</a:t>
-            </a:r>
-          </a:p>
-        </p:txBody>
-      </p:sp>
-      <p:sp>
-        <p:nvSpPr>
-          <p:cNvPr name="TextBox 17" id="17"/>
+              <a:t>place of birth:</a:t>
+            </a:r>
+          </a:p>
+        </p:txBody>
+      </p:sp>
+      <p:sp>
+        <p:nvSpPr>
+          <p:cNvPr name="TextBox 18" id="18"/>
           <p:cNvSpPr txBox="true"/>
           <p:nvPr/>
         </p:nvSpPr>
@@ -15259,14 +14873,14 @@
                   <a:srgbClr val="0000FF"/>
                 </a:solidFill>
               </a:rPr>
-              <a:t>1942-02-16</a:t>
-            </a:r>
-          </a:p>
-        </p:txBody>
-      </p:sp>
-      <p:sp>
-        <p:nvSpPr>
-          <p:cNvPr name="TextBox 18" id="18"/>
+              <a:t>Buckingham Palace (Q42182)</a:t>
+            </a:r>
+          </a:p>
+        </p:txBody>
+      </p:sp>
+      <p:sp>
+        <p:nvSpPr>
+          <p:cNvPr name="TextBox 19" id="19"/>
           <p:cNvSpPr txBox="true"/>
           <p:nvPr/>
         </p:nvSpPr>
@@ -15299,14 +14913,14 @@
                   <a:srgbClr val="000000"/>
                 </a:solidFill>
               </a:rPr>
-              <a:t>place of death:</a:t>
-            </a:r>
-          </a:p>
-        </p:txBody>
-      </p:sp>
-      <p:sp>
-        <p:nvSpPr>
-          <p:cNvPr name="TextBox 19" id="19"/>
+              <a:t>date of death:</a:t>
+            </a:r>
+          </a:p>
+        </p:txBody>
+      </p:sp>
+      <p:sp>
+        <p:nvSpPr>
+          <p:cNvPr name="TextBox 20" id="20"/>
           <p:cNvSpPr txBox="true"/>
           <p:nvPr/>
         </p:nvSpPr>
@@ -15339,14 +14953,14 @@
                   <a:srgbClr val="0000FF"/>
                 </a:solidFill>
               </a:rPr>
-              <a:t>Bagshot Park (Q582085)</a:t>
-            </a:r>
-          </a:p>
-        </p:txBody>
-      </p:sp>
-      <p:sp>
-        <p:nvSpPr>
-          <p:cNvPr name="TextBox 20" id="20"/>
+              <a:t>1942-01-16</a:t>
+            </a:r>
+          </a:p>
+        </p:txBody>
+      </p:sp>
+      <p:sp>
+        <p:nvSpPr>
+          <p:cNvPr name="TextBox 21" id="21"/>
           <p:cNvSpPr txBox="true"/>
           <p:nvPr/>
         </p:nvSpPr>
@@ -15379,14 +14993,14 @@
                   <a:srgbClr val="000000"/>
                 </a:solidFill>
               </a:rPr>
-              <a:t>wiki_en:</a:t>
-            </a:r>
-          </a:p>
-        </p:txBody>
-      </p:sp>
-      <p:sp>
-        <p:nvSpPr>
-          <p:cNvPr name="TextBox 21" id="21"/>
+              <a:t>place of death:</a:t>
+            </a:r>
+          </a:p>
+        </p:txBody>
+      </p:sp>
+      <p:sp>
+        <p:nvSpPr>
+          <p:cNvPr name="TextBox 22" id="22"/>
           <p:cNvSpPr txBox="true"/>
           <p:nvPr/>
         </p:nvSpPr>
@@ -15414,19 +15028,19 @@
           </a:p>
           <a:p>
             <a:r>
-              <a:rPr lang="en-US" sz="1200">
+              <a:rPr lang="en-US" sz="1600">
                 <a:solidFill>
                   <a:srgbClr val="0000FF"/>
                 </a:solidFill>
               </a:rPr>
-              <a:t>Prince Arthur, Duke of Connaught and Strathearn</a:t>
-            </a:r>
-          </a:p>
-        </p:txBody>
-      </p:sp>
-      <p:sp>
-        <p:nvSpPr>
-          <p:cNvPr name="TextBox 22" id="22"/>
+              <a:t>Bagshot Park (Q582085)</a:t>
+            </a:r>
+          </a:p>
+        </p:txBody>
+      </p:sp>
+      <p:sp>
+        <p:nvSpPr>
+          <p:cNvPr name="TextBox 23" id="23"/>
           <p:cNvSpPr txBox="true"/>
           <p:nvPr/>
         </p:nvSpPr>
@@ -15459,14 +15073,14 @@
                   <a:srgbClr val="000000"/>
                 </a:solidFill>
               </a:rPr>
-              <a:t>label_en:</a:t>
-            </a:r>
-          </a:p>
-        </p:txBody>
-      </p:sp>
-      <p:sp>
-        <p:nvSpPr>
-          <p:cNvPr name="TextBox 23" id="23"/>
+              <a:t>wiki_en:</a:t>
+            </a:r>
+          </a:p>
+        </p:txBody>
+      </p:sp>
+      <p:sp>
+        <p:nvSpPr>
+          <p:cNvPr name="TextBox 24" id="24"/>
           <p:cNvSpPr txBox="true"/>
           <p:nvPr/>
         </p:nvSpPr>
@@ -15506,7 +15120,7 @@
       </p:sp>
       <p:sp>
         <p:nvSpPr>
-          <p:cNvPr name="TextBox 24" id="24"/>
+          <p:cNvPr name="TextBox 25" id="25"/>
           <p:cNvSpPr txBox="true"/>
           <p:nvPr/>
         </p:nvSpPr>
@@ -15539,6 +15153,86 @@
                   <a:srgbClr val="000000"/>
                 </a:solidFill>
               </a:rPr>
+              <a:t>label_en:</a:t>
+            </a:r>
+          </a:p>
+        </p:txBody>
+      </p:sp>
+      <p:sp>
+        <p:nvSpPr>
+          <p:cNvPr name="TextBox 26" id="26"/>
+          <p:cNvSpPr txBox="true"/>
+          <p:nvPr/>
+        </p:nvSpPr>
+        <p:spPr>
+          <a:xfrm>
+            <a:off x="4445000" y="3606800"/>
+            <a:ext cx="4445000" cy="304800"/>
+          </a:xfrm>
+          <a:prstGeom prst="rect">
+            <a:avLst/>
+          </a:prstGeom>
+        </p:spPr>
+        <p:txBody>
+          <a:bodyPr anchor="t" rtlCol="false"/>
+          <a:lstStyle/>
+          <a:p>
+            <a:pPr algn="l">
+              <a:defRPr/>
+            </a:pPr>
+            <a:r>
+              <a:rPr lang="de-DE"/>
+              <a:t/>
+            </a:r>
+            <a:endParaRPr lang="en-US" sz="1100"/>
+          </a:p>
+          <a:p>
+            <a:r>
+              <a:rPr lang="en-US" sz="1200">
+                <a:solidFill>
+                  <a:srgbClr val="0000FF"/>
+                </a:solidFill>
+              </a:rPr>
+              <a:t>Prince Arthur, Duke of Connaught and Strathearn</a:t>
+            </a:r>
+          </a:p>
+        </p:txBody>
+      </p:sp>
+      <p:sp>
+        <p:nvSpPr>
+          <p:cNvPr name="TextBox 27" id="27"/>
+          <p:cNvSpPr txBox="true"/>
+          <p:nvPr/>
+        </p:nvSpPr>
+        <p:spPr>
+          <a:xfrm>
+            <a:off x="2984500" y="3911600"/>
+            <a:ext cx="1460500" cy="304800"/>
+          </a:xfrm>
+          <a:prstGeom prst="rect">
+            <a:avLst/>
+          </a:prstGeom>
+        </p:spPr>
+        <p:txBody>
+          <a:bodyPr anchor="t" rtlCol="false"/>
+          <a:lstStyle/>
+          <a:p>
+            <a:pPr algn="l">
+              <a:defRPr/>
+            </a:pPr>
+            <a:r>
+              <a:rPr lang="de-DE"/>
+              <a:t/>
+            </a:r>
+            <a:endParaRPr lang="en-US" sz="1100"/>
+          </a:p>
+          <a:p>
+            <a:r>
+              <a:rPr lang="en-US" sz="1600">
+                <a:solidFill>
+                  <a:srgbClr val="000000"/>
+                </a:solidFill>
+              </a:rPr>
               <a:t>source:</a:t>
             </a:r>
           </a:p>
@@ -15546,13 +15240,13 @@
       </p:sp>
       <p:sp>
         <p:nvSpPr>
-          <p:cNvPr name="TextBox 25" id="25"/>
-          <p:cNvSpPr txBox="true"/>
-          <p:nvPr/>
-        </p:nvSpPr>
-        <p:spPr>
-          <a:xfrm>
-            <a:off x="4445000" y="3606800"/>
+          <p:cNvPr name="TextBox 28" id="28"/>
+          <p:cNvSpPr txBox="true"/>
+          <p:nvPr/>
+        </p:nvSpPr>
+        <p:spPr>
+          <a:xfrm>
+            <a:off x="4445000" y="3911600"/>
             <a:ext cx="4445000" cy="304800"/>
           </a:xfrm>
           <a:prstGeom prst="rect">
@@ -16189,7 +15883,7 @@
                   <a:srgbClr val="0000FF"/>
                 </a:solidFill>
               </a:rPr>
-              <a:t>1853-05-07</a:t>
+              <a:t>1853-04-07</a:t>
             </a:r>
           </a:p>
         </p:txBody>
@@ -16349,7 +16043,7 @@
                   <a:srgbClr val="0000FF"/>
                 </a:solidFill>
               </a:rPr>
-              <a:t>1884-04-28</a:t>
+              <a:t>1884-03-28</a:t>
             </a:r>
           </a:p>
         </p:txBody>

</xml_diff>